<commit_message>
small change chunk 9
</commit_message>
<xml_diff>
--- a/Lectures/Chunk 9 - Matplotlib.pptx
+++ b/Lectures/Chunk 9 - Matplotlib.pptx
@@ -213,7 +213,7 @@
   <pc:docChgLst>
     <pc:chgData name="Jonathan Bollig" userId="8b5d0afe-f106-45e0-8c3f-fd98fa124db1" providerId="ADAL" clId="{B2469FA9-EBD8-4834-A16D-CBF8EFC907DD}"/>
     <pc:docChg chg="custSel addSld delSld modSld">
-      <pc:chgData name="Jonathan Bollig" userId="8b5d0afe-f106-45e0-8c3f-fd98fa124db1" providerId="ADAL" clId="{B2469FA9-EBD8-4834-A16D-CBF8EFC907DD}" dt="2025-10-07T00:02:20.001" v="20" actId="20577"/>
+      <pc:chgData name="Jonathan Bollig" userId="8b5d0afe-f106-45e0-8c3f-fd98fa124db1" providerId="ADAL" clId="{B2469FA9-EBD8-4834-A16D-CBF8EFC907DD}" dt="2025-10-07T16:34:13.962" v="39" actId="20577"/>
       <pc:docMkLst>
         <pc:docMk/>
       </pc:docMkLst>
@@ -274,6 +274,21 @@
           <pc:docMk/>
           <pc:sldMk cId="2113368255" sldId="269"/>
         </pc:sldMkLst>
+      </pc:sldChg>
+      <pc:sldChg chg="modSp mod">
+        <pc:chgData name="Jonathan Bollig" userId="8b5d0afe-f106-45e0-8c3f-fd98fa124db1" providerId="ADAL" clId="{B2469FA9-EBD8-4834-A16D-CBF8EFC907DD}" dt="2025-10-07T16:34:13.962" v="39" actId="20577"/>
+        <pc:sldMkLst>
+          <pc:docMk/>
+          <pc:sldMk cId="2693992445" sldId="271"/>
+        </pc:sldMkLst>
+        <pc:spChg chg="mod">
+          <ac:chgData name="Jonathan Bollig" userId="8b5d0afe-f106-45e0-8c3f-fd98fa124db1" providerId="ADAL" clId="{B2469FA9-EBD8-4834-A16D-CBF8EFC907DD}" dt="2025-10-07T16:34:13.962" v="39" actId="20577"/>
+          <ac:spMkLst>
+            <pc:docMk/>
+            <pc:sldMk cId="2693992445" sldId="271"/>
+            <ac:spMk id="2" creationId="{1402727D-356B-AE56-D94A-0E5E42768C9A}"/>
+          </ac:spMkLst>
+        </pc:spChg>
       </pc:sldChg>
     </pc:docChg>
   </pc:docChgLst>
@@ -4308,7 +4323,7 @@
           <a:p>
             <a:r>
               <a:rPr lang="en-US" noProof="0" dirty="0"/>
-              <a:t>Getting Started</a:t>
+              <a:t>Live Coding: Getting Started</a:t>
             </a:r>
           </a:p>
         </p:txBody>

</xml_diff>